<commit_message>
updated ppt, and budget
</commit_message>
<xml_diff>
--- a/docs/ShopSage_Pitch.pptx
+++ b/docs/ShopSage_Pitch.pptx
@@ -6226,7 +6226,7 @@
                 <a:ea typeface="Playfair Display" pitchFamily="34" charset="-122"/>
                 <a:cs typeface="Playfair Display" pitchFamily="34" charset="-120"/>
               </a:rPr>
-              <a:t>__ %</a:t>
+              <a:t>20 %</a:t>
             </a:r>
             <a:endParaRPr lang="en-US" sz="2200" dirty="0"/>
           </a:p>
@@ -6338,7 +6338,7 @@
                 <a:ea typeface="Playfair Display" pitchFamily="34" charset="-122"/>
                 <a:cs typeface="Playfair Display" pitchFamily="34" charset="-120"/>
               </a:rPr>
-              <a:t>__ by rule</a:t>
+              <a:t>5</a:t>
             </a:r>
             <a:endParaRPr lang="en-US" sz="2200" dirty="0"/>
           </a:p>
@@ -6377,7 +6377,7 @@
                 <a:ea typeface="Inter" pitchFamily="34" charset="-122"/>
                 <a:cs typeface="Inter" pitchFamily="34" charset="-120"/>
               </a:rPr>
-              <a:t>Guardrail triggers</a:t>
+              <a:t>Guardrail triggers · 4 stock, 1 age</a:t>
             </a:r>
             <a:endParaRPr lang="en-US" sz="1050" dirty="0"/>
           </a:p>
@@ -6450,7 +6450,7 @@
                 <a:ea typeface="Playfair Display" pitchFamily="34" charset="-122"/>
                 <a:cs typeface="Playfair Display" pitchFamily="34" charset="-120"/>
               </a:rPr>
-              <a:t>__ ms</a:t>
+              <a:t>3,442 ms</a:t>
             </a:r>
             <a:endParaRPr lang="en-US" sz="2200" dirty="0"/>
           </a:p>
@@ -6562,7 +6562,7 @@
                 <a:ea typeface="Playfair Display" pitchFamily="34" charset="-122"/>
                 <a:cs typeface="Playfair Display" pitchFamily="34" charset="-120"/>
               </a:rPr>
-              <a:t>__ %</a:t>
+              <a:t>0 %</a:t>
             </a:r>
             <a:endParaRPr lang="en-US" sz="2200" dirty="0"/>
           </a:p>
@@ -6640,7 +6640,7 @@
                 <a:ea typeface="Inter" pitchFamily="34" charset="-122"/>
                 <a:cs typeface="Inter" pitchFamily="34" charset="-120"/>
               </a:rPr>
-              <a:t>Fill from /api/dashboard after a live demo session.</a:t>
+              <a:t>Live /api/dashboard readout — 6-turn session: RAG search, cached repeat, cross-session memory, both MCP tools, both guardrails.</a:t>
             </a:r>
             <a:endParaRPr lang="en-US" sz="1000" dirty="0"/>
           </a:p>

</xml_diff>